<commit_message>
Certificado: nuevas esquinas y más detalle de fondo
Se quitan los esquineros en L y las líneas finas de las esquinas libres.
En su lugar hay tres opciones de adorno (ondas suaves, trama de puntos o
arcos dorados) seleccionables con ESQUINAS; la predeterminada es ondas.
El fondo suma el edificio del logo como marca de agua tenue detrás del
nombre y el folio pasa al centro inferior.

Co-Authored-By: Claude Opus 5.5 <noreply@anthropic.com>
Claude-Session: https://claude.ai/code/session_012sd5bSKMPYV9SR5BJywH7e
</commit_message>
<xml_diff>
--- a/presentaciones/medical-leadership-summit-2026/Certificados_Medical_Leadership_Summit_2026.pptx
+++ b/presentaciones/medical-leadership-summit-2026/Certificados_Medical_Leadership_Summit_2026.pptx
@@ -1551,7 +1551,7 @@
         </p:nvSpPr>
         <p:spPr>
           <a:xfrm>
-            <a:off x="5989320" y="786384"/>
+            <a:off x="5532120" y="786384"/>
             <a:ext cx="3200400" cy="274320"/>
           </a:xfrm>
           <a:prstGeom prst="rect">
@@ -1590,7 +1590,7 @@
         </p:nvSpPr>
         <p:spPr>
           <a:xfrm>
-            <a:off x="5989320" y="1024128"/>
+            <a:off x="5532120" y="1024128"/>
             <a:ext cx="3200400" cy="292608"/>
           </a:xfrm>
           <a:prstGeom prst="rect">
@@ -1629,7 +1629,7 @@
         </p:nvSpPr>
         <p:spPr>
           <a:xfrm>
-            <a:off x="5989320" y="1298448"/>
+            <a:off x="5532120" y="1298448"/>
             <a:ext cx="3200400" cy="274320"/>
           </a:xfrm>
           <a:prstGeom prst="rect">
@@ -1668,7 +1668,7 @@
         </p:nvSpPr>
         <p:spPr>
           <a:xfrm>
-            <a:off x="8686800" y="1645920"/>
+            <a:off x="8229600" y="1645920"/>
             <a:ext cx="502920" cy="45720"/>
           </a:xfrm>
           <a:prstGeom prst="rect">
@@ -2625,20 +2625,20 @@
         </p:nvSpPr>
         <p:spPr>
           <a:xfrm>
-            <a:off x="868680" y="6839712"/>
-            <a:ext cx="2377440" cy="182880"/>
-          </a:xfrm>
-          <a:prstGeom prst="rect">
-            <a:avLst/>
-          </a:prstGeom>
-          <a:noFill/>
-          <a:ln/>
-        </p:spPr>
-        <p:txBody>
-          <a:bodyPr wrap="square" lIns="0" tIns="0" rIns="0" bIns="0" rtlCol="0" anchor="ctr"/>
-          <a:lstStyle/>
-          <a:p>
-            <a:pPr algn="l" indent="0" marL="0">
+            <a:off x="3657600" y="7370064"/>
+            <a:ext cx="2743200" cy="182880"/>
+          </a:xfrm>
+          <a:prstGeom prst="rect">
+            <a:avLst/>
+          </a:prstGeom>
+          <a:noFill/>
+          <a:ln/>
+        </p:spPr>
+        <p:txBody>
+          <a:bodyPr wrap="square" lIns="0" tIns="0" rIns="0" bIns="0" rtlCol="0" anchor="ctr"/>
+          <a:lstStyle/>
+          <a:p>
+            <a:pPr algn="ctr" indent="0" marL="0">
               <a:buNone/>
             </a:pPr>
             <a:r>
@@ -3318,20 +3318,20 @@
         </p:nvSpPr>
         <p:spPr>
           <a:xfrm>
-            <a:off x="868680" y="6839712"/>
-            <a:ext cx="2377440" cy="182880"/>
-          </a:xfrm>
-          <a:prstGeom prst="rect">
-            <a:avLst/>
-          </a:prstGeom>
-          <a:noFill/>
-          <a:ln/>
-        </p:spPr>
-        <p:txBody>
-          <a:bodyPr wrap="square" lIns="0" tIns="0" rIns="0" bIns="0" rtlCol="0" anchor="ctr"/>
-          <a:lstStyle/>
-          <a:p>
-            <a:pPr algn="l" indent="0" marL="0">
+            <a:off x="3657600" y="7370064"/>
+            <a:ext cx="2743200" cy="182880"/>
+          </a:xfrm>
+          <a:prstGeom prst="rect">
+            <a:avLst/>
+          </a:prstGeom>
+          <a:noFill/>
+          <a:ln/>
+        </p:spPr>
+        <p:txBody>
+          <a:bodyPr wrap="square" lIns="0" tIns="0" rIns="0" bIns="0" rtlCol="0" anchor="ctr"/>
+          <a:lstStyle/>
+          <a:p>
+            <a:pPr algn="ctr" indent="0" marL="0">
               <a:buNone/>
             </a:pPr>
             <a:r>
@@ -4011,20 +4011,20 @@
         </p:nvSpPr>
         <p:spPr>
           <a:xfrm>
-            <a:off x="868680" y="6839712"/>
-            <a:ext cx="2377440" cy="182880"/>
-          </a:xfrm>
-          <a:prstGeom prst="rect">
-            <a:avLst/>
-          </a:prstGeom>
-          <a:noFill/>
-          <a:ln/>
-        </p:spPr>
-        <p:txBody>
-          <a:bodyPr wrap="square" lIns="0" tIns="0" rIns="0" bIns="0" rtlCol="0" anchor="ctr"/>
-          <a:lstStyle/>
-          <a:p>
-            <a:pPr algn="l" indent="0" marL="0">
+            <a:off x="3657600" y="7370064"/>
+            <a:ext cx="2743200" cy="182880"/>
+          </a:xfrm>
+          <a:prstGeom prst="rect">
+            <a:avLst/>
+          </a:prstGeom>
+          <a:noFill/>
+          <a:ln/>
+        </p:spPr>
+        <p:txBody>
+          <a:bodyPr wrap="square" lIns="0" tIns="0" rIns="0" bIns="0" rtlCol="0" anchor="ctr"/>
+          <a:lstStyle/>
+          <a:p>
+            <a:pPr algn="ctr" indent="0" marL="0">
               <a:buNone/>
             </a:pPr>
             <a:r>
@@ -4704,20 +4704,20 @@
         </p:nvSpPr>
         <p:spPr>
           <a:xfrm>
-            <a:off x="868680" y="6839712"/>
-            <a:ext cx="2377440" cy="182880"/>
-          </a:xfrm>
-          <a:prstGeom prst="rect">
-            <a:avLst/>
-          </a:prstGeom>
-          <a:noFill/>
-          <a:ln/>
-        </p:spPr>
-        <p:txBody>
-          <a:bodyPr wrap="square" lIns="0" tIns="0" rIns="0" bIns="0" rtlCol="0" anchor="ctr"/>
-          <a:lstStyle/>
-          <a:p>
-            <a:pPr algn="l" indent="0" marL="0">
+            <a:off x="3657600" y="7370064"/>
+            <a:ext cx="2743200" cy="182880"/>
+          </a:xfrm>
+          <a:prstGeom prst="rect">
+            <a:avLst/>
+          </a:prstGeom>
+          <a:noFill/>
+          <a:ln/>
+        </p:spPr>
+        <p:txBody>
+          <a:bodyPr wrap="square" lIns="0" tIns="0" rIns="0" bIns="0" rtlCol="0" anchor="ctr"/>
+          <a:lstStyle/>
+          <a:p>
+            <a:pPr algn="ctr" indent="0" marL="0">
               <a:buNone/>
             </a:pPr>
             <a:r>
@@ -5397,20 +5397,20 @@
         </p:nvSpPr>
         <p:spPr>
           <a:xfrm>
-            <a:off x="868680" y="6839712"/>
-            <a:ext cx="2377440" cy="182880"/>
-          </a:xfrm>
-          <a:prstGeom prst="rect">
-            <a:avLst/>
-          </a:prstGeom>
-          <a:noFill/>
-          <a:ln/>
-        </p:spPr>
-        <p:txBody>
-          <a:bodyPr wrap="square" lIns="0" tIns="0" rIns="0" bIns="0" rtlCol="0" anchor="ctr"/>
-          <a:lstStyle/>
-          <a:p>
-            <a:pPr algn="l" indent="0" marL="0">
+            <a:off x="3657600" y="7370064"/>
+            <a:ext cx="2743200" cy="182880"/>
+          </a:xfrm>
+          <a:prstGeom prst="rect">
+            <a:avLst/>
+          </a:prstGeom>
+          <a:noFill/>
+          <a:ln/>
+        </p:spPr>
+        <p:txBody>
+          <a:bodyPr wrap="square" lIns="0" tIns="0" rIns="0" bIns="0" rtlCol="0" anchor="ctr"/>
+          <a:lstStyle/>
+          <a:p>
+            <a:pPr algn="ctr" indent="0" marL="0">
               <a:buNone/>
             </a:pPr>
             <a:r>
@@ -6090,20 +6090,20 @@
         </p:nvSpPr>
         <p:spPr>
           <a:xfrm>
-            <a:off x="868680" y="6839712"/>
-            <a:ext cx="2377440" cy="182880"/>
-          </a:xfrm>
-          <a:prstGeom prst="rect">
-            <a:avLst/>
-          </a:prstGeom>
-          <a:noFill/>
-          <a:ln/>
-        </p:spPr>
-        <p:txBody>
-          <a:bodyPr wrap="square" lIns="0" tIns="0" rIns="0" bIns="0" rtlCol="0" anchor="ctr"/>
-          <a:lstStyle/>
-          <a:p>
-            <a:pPr algn="l" indent="0" marL="0">
+            <a:off x="3657600" y="7370064"/>
+            <a:ext cx="2743200" cy="182880"/>
+          </a:xfrm>
+          <a:prstGeom prst="rect">
+            <a:avLst/>
+          </a:prstGeom>
+          <a:noFill/>
+          <a:ln/>
+        </p:spPr>
+        <p:txBody>
+          <a:bodyPr wrap="square" lIns="0" tIns="0" rIns="0" bIns="0" rtlCol="0" anchor="ctr"/>
+          <a:lstStyle/>
+          <a:p>
+            <a:pPr algn="ctr" indent="0" marL="0">
               <a:buNone/>
             </a:pPr>
             <a:r>
@@ -6783,20 +6783,20 @@
         </p:nvSpPr>
         <p:spPr>
           <a:xfrm>
-            <a:off x="868680" y="6839712"/>
-            <a:ext cx="2377440" cy="182880"/>
-          </a:xfrm>
-          <a:prstGeom prst="rect">
-            <a:avLst/>
-          </a:prstGeom>
-          <a:noFill/>
-          <a:ln/>
-        </p:spPr>
-        <p:txBody>
-          <a:bodyPr wrap="square" lIns="0" tIns="0" rIns="0" bIns="0" rtlCol="0" anchor="ctr"/>
-          <a:lstStyle/>
-          <a:p>
-            <a:pPr algn="l" indent="0" marL="0">
+            <a:off x="3657600" y="7370064"/>
+            <a:ext cx="2743200" cy="182880"/>
+          </a:xfrm>
+          <a:prstGeom prst="rect">
+            <a:avLst/>
+          </a:prstGeom>
+          <a:noFill/>
+          <a:ln/>
+        </p:spPr>
+        <p:txBody>
+          <a:bodyPr wrap="square" lIns="0" tIns="0" rIns="0" bIns="0" rtlCol="0" anchor="ctr"/>
+          <a:lstStyle/>
+          <a:p>
+            <a:pPr algn="ctr" indent="0" marL="0">
               <a:buNone/>
             </a:pPr>
             <a:r>
@@ -7476,20 +7476,20 @@
         </p:nvSpPr>
         <p:spPr>
           <a:xfrm>
-            <a:off x="868680" y="6839712"/>
-            <a:ext cx="2377440" cy="182880"/>
-          </a:xfrm>
-          <a:prstGeom prst="rect">
-            <a:avLst/>
-          </a:prstGeom>
-          <a:noFill/>
-          <a:ln/>
-        </p:spPr>
-        <p:txBody>
-          <a:bodyPr wrap="square" lIns="0" tIns="0" rIns="0" bIns="0" rtlCol="0" anchor="ctr"/>
-          <a:lstStyle/>
-          <a:p>
-            <a:pPr algn="l" indent="0" marL="0">
+            <a:off x="3657600" y="7370064"/>
+            <a:ext cx="2743200" cy="182880"/>
+          </a:xfrm>
+          <a:prstGeom prst="rect">
+            <a:avLst/>
+          </a:prstGeom>
+          <a:noFill/>
+          <a:ln/>
+        </p:spPr>
+        <p:txBody>
+          <a:bodyPr wrap="square" lIns="0" tIns="0" rIns="0" bIns="0" rtlCol="0" anchor="ctr"/>
+          <a:lstStyle/>
+          <a:p>
+            <a:pPr algn="ctr" indent="0" marL="0">
               <a:buNone/>
             </a:pPr>
             <a:r>
@@ -8169,20 +8169,20 @@
         </p:nvSpPr>
         <p:spPr>
           <a:xfrm>
-            <a:off x="868680" y="6839712"/>
-            <a:ext cx="2377440" cy="182880"/>
-          </a:xfrm>
-          <a:prstGeom prst="rect">
-            <a:avLst/>
-          </a:prstGeom>
-          <a:noFill/>
-          <a:ln/>
-        </p:spPr>
-        <p:txBody>
-          <a:bodyPr wrap="square" lIns="0" tIns="0" rIns="0" bIns="0" rtlCol="0" anchor="ctr"/>
-          <a:lstStyle/>
-          <a:p>
-            <a:pPr algn="l" indent="0" marL="0">
+            <a:off x="3657600" y="7370064"/>
+            <a:ext cx="2743200" cy="182880"/>
+          </a:xfrm>
+          <a:prstGeom prst="rect">
+            <a:avLst/>
+          </a:prstGeom>
+          <a:noFill/>
+          <a:ln/>
+        </p:spPr>
+        <p:txBody>
+          <a:bodyPr wrap="square" lIns="0" tIns="0" rIns="0" bIns="0" rtlCol="0" anchor="ctr"/>
+          <a:lstStyle/>
+          <a:p>
+            <a:pPr algn="ctr" indent="0" marL="0">
               <a:buNone/>
             </a:pPr>
             <a:r>
@@ -8862,20 +8862,20 @@
         </p:nvSpPr>
         <p:spPr>
           <a:xfrm>
-            <a:off x="868680" y="6839712"/>
-            <a:ext cx="2377440" cy="182880"/>
-          </a:xfrm>
-          <a:prstGeom prst="rect">
-            <a:avLst/>
-          </a:prstGeom>
-          <a:noFill/>
-          <a:ln/>
-        </p:spPr>
-        <p:txBody>
-          <a:bodyPr wrap="square" lIns="0" tIns="0" rIns="0" bIns="0" rtlCol="0" anchor="ctr"/>
-          <a:lstStyle/>
-          <a:p>
-            <a:pPr algn="l" indent="0" marL="0">
+            <a:off x="3657600" y="7370064"/>
+            <a:ext cx="2743200" cy="182880"/>
+          </a:xfrm>
+          <a:prstGeom prst="rect">
+            <a:avLst/>
+          </a:prstGeom>
+          <a:noFill/>
+          <a:ln/>
+        </p:spPr>
+        <p:txBody>
+          <a:bodyPr wrap="square" lIns="0" tIns="0" rIns="0" bIns="0" rtlCol="0" anchor="ctr"/>
+          <a:lstStyle/>
+          <a:p>
+            <a:pPr algn="ctr" indent="0" marL="0">
               <a:buNone/>
             </a:pPr>
             <a:r>
@@ -9555,20 +9555,20 @@
         </p:nvSpPr>
         <p:spPr>
           <a:xfrm>
-            <a:off x="868680" y="6839712"/>
-            <a:ext cx="2377440" cy="182880"/>
-          </a:xfrm>
-          <a:prstGeom prst="rect">
-            <a:avLst/>
-          </a:prstGeom>
-          <a:noFill/>
-          <a:ln/>
-        </p:spPr>
-        <p:txBody>
-          <a:bodyPr wrap="square" lIns="0" tIns="0" rIns="0" bIns="0" rtlCol="0" anchor="ctr"/>
-          <a:lstStyle/>
-          <a:p>
-            <a:pPr algn="l" indent="0" marL="0">
+            <a:off x="3657600" y="7370064"/>
+            <a:ext cx="2743200" cy="182880"/>
+          </a:xfrm>
+          <a:prstGeom prst="rect">
+            <a:avLst/>
+          </a:prstGeom>
+          <a:noFill/>
+          <a:ln/>
+        </p:spPr>
+        <p:txBody>
+          <a:bodyPr wrap="square" lIns="0" tIns="0" rIns="0" bIns="0" rtlCol="0" anchor="ctr"/>
+          <a:lstStyle/>
+          <a:p>
+            <a:pPr algn="ctr" indent="0" marL="0">
               <a:buNone/>
             </a:pPr>
             <a:r>

</xml_diff>

<commit_message>
Certificado: alternativas para la zona del logo y #SOMOSWESTHILL
Se agregan tres composiciones nuevas seleccionables con MARCO: banda
superior e inferior (predeterminada), logo a color centrado con marco
fino, y panel azul lateral; la de olas en esquinas sigue disponible.
Se regeneran el PPTX, el PDF y las vistas previas con la banda.

Co-Authored-By: Claude Opus 5.5 <noreply@anthropic.com>
Claude-Session: https://claude.ai/code/session_012sd5bSKMPYV9SR5BJywH7e
</commit_message>
<xml_diff>
--- a/presentaciones/medical-leadership-summit-2026/Certificados_Medical_Leadership_Summit_2026.pptx
+++ b/presentaciones/medical-leadership-summit-2026/Certificados_Medical_Leadership_Summit_2026.pptx
@@ -1511,8 +1511,8 @@
         </p:blipFill>
         <p:spPr>
           <a:xfrm>
-            <a:off x="420624" y="329184"/>
-            <a:ext cx="2240280" cy="903031"/>
+            <a:off x="457200" y="155448"/>
+            <a:ext cx="2011680" cy="810885"/>
           </a:xfrm>
           <a:prstGeom prst="rect">
             <a:avLst/>
@@ -1551,8 +1551,8 @@
         </p:nvSpPr>
         <p:spPr>
           <a:xfrm>
-            <a:off x="5532120" y="786384"/>
-            <a:ext cx="3200400" cy="274320"/>
+            <a:off x="6035040" y="109728"/>
+            <a:ext cx="3566160" cy="274320"/>
           </a:xfrm>
           <a:prstGeom prst="rect">
             <a:avLst/>
@@ -1568,9 +1568,9 @@
               <a:buNone/>
             </a:pPr>
             <a:r>
-              <a:rPr lang="en-US" sz="1500" spc="200" kern="0" dirty="0">
-                <a:solidFill>
-                  <a:srgbClr val="266294"/>
+              <a:rPr lang="en-US" sz="1300" spc="200" kern="0" dirty="0">
+                <a:solidFill>
+                  <a:srgbClr val="FFFFFF"/>
                 </a:solidFill>
                 <a:latin typeface="Montserrat" pitchFamily="34" charset="0"/>
                 <a:ea typeface="Montserrat" pitchFamily="34" charset="-122"/>
@@ -1578,7 +1578,7 @@
               </a:rPr>
               <a:t>WESTHILL</a:t>
             </a:r>
-            <a:endParaRPr lang="en-US" sz="1500" dirty="0"/>
+            <a:endParaRPr lang="en-US" sz="1300" dirty="0"/>
           </a:p>
         </p:txBody>
       </p:sp>
@@ -1590,8 +1590,8 @@
         </p:nvSpPr>
         <p:spPr>
           <a:xfrm>
-            <a:off x="5532120" y="1024128"/>
-            <a:ext cx="3200400" cy="292608"/>
+            <a:off x="6035040" y="347472"/>
+            <a:ext cx="3566160" cy="292608"/>
           </a:xfrm>
           <a:prstGeom prst="rect">
             <a:avLst/>
@@ -1607,9 +1607,9 @@
               <a:buNone/>
             </a:pPr>
             <a:r>
-              <a:rPr lang="en-US" sz="1700" dirty="0">
-                <a:solidFill>
-                  <a:srgbClr val="266294"/>
+              <a:rPr lang="en-US" sz="1600" dirty="0">
+                <a:solidFill>
+                  <a:srgbClr val="FFFFFF"/>
                 </a:solidFill>
                 <a:latin typeface="Montserrat ExtraBold" pitchFamily="34" charset="0"/>
                 <a:ea typeface="Montserrat ExtraBold" pitchFamily="34" charset="-122"/>
@@ -1617,7 +1617,7 @@
               </a:rPr>
               <a:t>MEDICAL LEADERSHIP</a:t>
             </a:r>
-            <a:endParaRPr lang="en-US" sz="1700" dirty="0"/>
+            <a:endParaRPr lang="en-US" sz="1600" dirty="0"/>
           </a:p>
         </p:txBody>
       </p:sp>
@@ -1629,8 +1629,8 @@
         </p:nvSpPr>
         <p:spPr>
           <a:xfrm>
-            <a:off x="5532120" y="1298448"/>
-            <a:ext cx="3200400" cy="274320"/>
+            <a:off x="6035040" y="621792"/>
+            <a:ext cx="3566160" cy="274320"/>
           </a:xfrm>
           <a:prstGeom prst="rect">
             <a:avLst/>
@@ -1646,9 +1646,9 @@
               <a:buNone/>
             </a:pPr>
             <a:r>
-              <a:rPr lang="en-US" sz="1500" dirty="0">
-                <a:solidFill>
-                  <a:srgbClr val="266294"/>
+              <a:rPr lang="en-US" sz="1300" dirty="0">
+                <a:solidFill>
+                  <a:srgbClr val="FFFFFF"/>
                 </a:solidFill>
                 <a:latin typeface="Montserrat" pitchFamily="34" charset="0"/>
                 <a:ea typeface="Montserrat" pitchFamily="34" charset="-122"/>
@@ -1656,29 +1656,48 @@
               </a:rPr>
               <a:t>SUMMIT 2026</a:t>
             </a:r>
-            <a:endParaRPr lang="en-US" sz="1500" dirty="0"/>
-          </a:p>
-        </p:txBody>
-      </p:sp>
-      <p:sp>
-        <p:nvSpPr>
-          <p:cNvPr id="7" name="Shape 3"/>
+            <a:endParaRPr lang="en-US" sz="1300" dirty="0"/>
+          </a:p>
+        </p:txBody>
+      </p:sp>
+      <p:sp>
+        <p:nvSpPr>
+          <p:cNvPr id="7" name="Text 3"/>
           <p:cNvSpPr/>
           <p:nvPr/>
         </p:nvSpPr>
         <p:spPr>
           <a:xfrm>
-            <a:off x="8229600" y="1645920"/>
-            <a:ext cx="502920" cy="45720"/>
-          </a:xfrm>
-          <a:prstGeom prst="rect">
-            <a:avLst/>
-          </a:prstGeom>
-          <a:solidFill>
-            <a:srgbClr val="2DB34A"/>
-          </a:solidFill>
-          <a:ln/>
-        </p:spPr>
+            <a:off x="2743200" y="7498080"/>
+            <a:ext cx="4572000" cy="219456"/>
+          </a:xfrm>
+          <a:prstGeom prst="rect">
+            <a:avLst/>
+          </a:prstGeom>
+          <a:noFill/>
+          <a:ln/>
+        </p:spPr>
+        <p:txBody>
+          <a:bodyPr wrap="square" lIns="0" tIns="0" rIns="0" bIns="0" rtlCol="0" anchor="ctr"/>
+          <a:lstStyle/>
+          <a:p>
+            <a:pPr algn="ctr" indent="0" marL="0">
+              <a:buNone/>
+            </a:pPr>
+            <a:r>
+              <a:rPr lang="en-US" sz="950" spc="100" kern="0" dirty="0">
+                <a:solidFill>
+                  <a:srgbClr val="FFFFFF"/>
+                </a:solidFill>
+                <a:latin typeface="Montserrat SemiBold" pitchFamily="34" charset="0"/>
+                <a:ea typeface="Montserrat SemiBold" pitchFamily="34" charset="-122"/>
+                <a:cs typeface="Montserrat SemiBold" pitchFamily="34" charset="-120"/>
+              </a:rPr>
+              <a:t>21, 22 y 23 de octubre de 2026  ·  Facultad de Medicina</a:t>
+            </a:r>
+            <a:endParaRPr lang="en-US" sz="950" dirty="0"/>
+          </a:p>
+        </p:txBody>
       </p:sp>
       <p:sp>
         <p:nvSpPr>
@@ -1688,8 +1707,8 @@
         </p:nvSpPr>
         <p:spPr>
           <a:xfrm>
-            <a:off x="7818120" y="7296912"/>
-            <a:ext cx="2011680" cy="237744"/>
+            <a:off x="7589520" y="7498080"/>
+            <a:ext cx="2011680" cy="219456"/>
           </a:xfrm>
           <a:prstGeom prst="rect">
             <a:avLst/>
@@ -1707,7 +1726,7 @@
             <a:r>
               <a:rPr lang="en-US" sz="1000" spc="150" kern="0" dirty="0">
                 <a:solidFill>
-                  <a:srgbClr val="FFFFFF"/>
+                  <a:srgbClr val="F2C94C"/>
                 </a:solidFill>
                 <a:latin typeface="Montserrat ExtraBold" pitchFamily="34" charset="0"/>
                 <a:ea typeface="Montserrat ExtraBold" pitchFamily="34" charset="-122"/>
@@ -2030,8 +2049,8 @@
         </p:nvSpPr>
         <p:spPr>
           <a:xfrm>
-            <a:off x="3200400" y="1536192"/>
-            <a:ext cx="3657600" cy="237744"/>
+            <a:off x="1188720" y="1536192"/>
+            <a:ext cx="7680960" cy="237744"/>
           </a:xfrm>
           <a:prstGeom prst="rect">
             <a:avLst/>
@@ -2069,8 +2088,8 @@
         </p:nvSpPr>
         <p:spPr>
           <a:xfrm>
-            <a:off x="1371600" y="1737360"/>
-            <a:ext cx="7315200" cy="777240"/>
+            <a:off x="1097280" y="1737360"/>
+            <a:ext cx="7863840" cy="777240"/>
           </a:xfrm>
           <a:prstGeom prst="rect">
             <a:avLst/>
@@ -2625,26 +2644,26 @@
         </p:nvSpPr>
         <p:spPr>
           <a:xfrm>
-            <a:off x="3657600" y="7370064"/>
-            <a:ext cx="2743200" cy="182880"/>
-          </a:xfrm>
-          <a:prstGeom prst="rect">
-            <a:avLst/>
-          </a:prstGeom>
-          <a:noFill/>
-          <a:ln/>
-        </p:spPr>
-        <p:txBody>
-          <a:bodyPr wrap="square" lIns="0" tIns="0" rIns="0" bIns="0" rtlCol="0" anchor="ctr"/>
-          <a:lstStyle/>
-          <a:p>
-            <a:pPr algn="ctr" indent="0" marL="0">
+            <a:off x="457200" y="7498080"/>
+            <a:ext cx="2286000" cy="219456"/>
+          </a:xfrm>
+          <a:prstGeom prst="rect">
+            <a:avLst/>
+          </a:prstGeom>
+          <a:noFill/>
+          <a:ln/>
+        </p:spPr>
+        <p:txBody>
+          <a:bodyPr wrap="square" lIns="0" tIns="0" rIns="0" bIns="0" rtlCol="0" anchor="ctr"/>
+          <a:lstStyle/>
+          <a:p>
+            <a:pPr algn="l" indent="0" marL="0">
               <a:buNone/>
             </a:pPr>
             <a:r>
               <a:rPr lang="en-US" sz="800" spc="100" kern="0" dirty="0">
                 <a:solidFill>
-                  <a:srgbClr val="8A99AB"/>
+                  <a:srgbClr val="CFE6FB"/>
                 </a:solidFill>
                 <a:latin typeface="Montserrat SemiBold" pitchFamily="34" charset="0"/>
                 <a:ea typeface="Montserrat SemiBold" pitchFamily="34" charset="-122"/>
@@ -2689,8 +2708,8 @@
         </p:nvSpPr>
         <p:spPr>
           <a:xfrm>
-            <a:off x="3200400" y="1536192"/>
-            <a:ext cx="3657600" cy="237744"/>
+            <a:off x="1188720" y="1536192"/>
+            <a:ext cx="7680960" cy="237744"/>
           </a:xfrm>
           <a:prstGeom prst="rect">
             <a:avLst/>
@@ -2728,8 +2747,8 @@
         </p:nvSpPr>
         <p:spPr>
           <a:xfrm>
-            <a:off x="1371600" y="1737360"/>
-            <a:ext cx="7315200" cy="777240"/>
+            <a:off x="1097280" y="1737360"/>
+            <a:ext cx="7863840" cy="777240"/>
           </a:xfrm>
           <a:prstGeom prst="rect">
             <a:avLst/>
@@ -3318,26 +3337,26 @@
         </p:nvSpPr>
         <p:spPr>
           <a:xfrm>
-            <a:off x="3657600" y="7370064"/>
-            <a:ext cx="2743200" cy="182880"/>
-          </a:xfrm>
-          <a:prstGeom prst="rect">
-            <a:avLst/>
-          </a:prstGeom>
-          <a:noFill/>
-          <a:ln/>
-        </p:spPr>
-        <p:txBody>
-          <a:bodyPr wrap="square" lIns="0" tIns="0" rIns="0" bIns="0" rtlCol="0" anchor="ctr"/>
-          <a:lstStyle/>
-          <a:p>
-            <a:pPr algn="ctr" indent="0" marL="0">
+            <a:off x="457200" y="7498080"/>
+            <a:ext cx="2286000" cy="219456"/>
+          </a:xfrm>
+          <a:prstGeom prst="rect">
+            <a:avLst/>
+          </a:prstGeom>
+          <a:noFill/>
+          <a:ln/>
+        </p:spPr>
+        <p:txBody>
+          <a:bodyPr wrap="square" lIns="0" tIns="0" rIns="0" bIns="0" rtlCol="0" anchor="ctr"/>
+          <a:lstStyle/>
+          <a:p>
+            <a:pPr algn="l" indent="0" marL="0">
               <a:buNone/>
             </a:pPr>
             <a:r>
               <a:rPr lang="en-US" sz="800" spc="100" kern="0" dirty="0">
                 <a:solidFill>
-                  <a:srgbClr val="8A99AB"/>
+                  <a:srgbClr val="CFE6FB"/>
                 </a:solidFill>
                 <a:latin typeface="Montserrat SemiBold" pitchFamily="34" charset="0"/>
                 <a:ea typeface="Montserrat SemiBold" pitchFamily="34" charset="-122"/>
@@ -3382,8 +3401,8 @@
         </p:nvSpPr>
         <p:spPr>
           <a:xfrm>
-            <a:off x="3200400" y="1536192"/>
-            <a:ext cx="3657600" cy="237744"/>
+            <a:off x="1188720" y="1536192"/>
+            <a:ext cx="7680960" cy="237744"/>
           </a:xfrm>
           <a:prstGeom prst="rect">
             <a:avLst/>
@@ -3421,8 +3440,8 @@
         </p:nvSpPr>
         <p:spPr>
           <a:xfrm>
-            <a:off x="1371600" y="1737360"/>
-            <a:ext cx="7315200" cy="777240"/>
+            <a:off x="1097280" y="1737360"/>
+            <a:ext cx="7863840" cy="777240"/>
           </a:xfrm>
           <a:prstGeom prst="rect">
             <a:avLst/>
@@ -4011,26 +4030,26 @@
         </p:nvSpPr>
         <p:spPr>
           <a:xfrm>
-            <a:off x="3657600" y="7370064"/>
-            <a:ext cx="2743200" cy="182880"/>
-          </a:xfrm>
-          <a:prstGeom prst="rect">
-            <a:avLst/>
-          </a:prstGeom>
-          <a:noFill/>
-          <a:ln/>
-        </p:spPr>
-        <p:txBody>
-          <a:bodyPr wrap="square" lIns="0" tIns="0" rIns="0" bIns="0" rtlCol="0" anchor="ctr"/>
-          <a:lstStyle/>
-          <a:p>
-            <a:pPr algn="ctr" indent="0" marL="0">
+            <a:off x="457200" y="7498080"/>
+            <a:ext cx="2286000" cy="219456"/>
+          </a:xfrm>
+          <a:prstGeom prst="rect">
+            <a:avLst/>
+          </a:prstGeom>
+          <a:noFill/>
+          <a:ln/>
+        </p:spPr>
+        <p:txBody>
+          <a:bodyPr wrap="square" lIns="0" tIns="0" rIns="0" bIns="0" rtlCol="0" anchor="ctr"/>
+          <a:lstStyle/>
+          <a:p>
+            <a:pPr algn="l" indent="0" marL="0">
               <a:buNone/>
             </a:pPr>
             <a:r>
               <a:rPr lang="en-US" sz="800" spc="100" kern="0" dirty="0">
                 <a:solidFill>
-                  <a:srgbClr val="8A99AB"/>
+                  <a:srgbClr val="CFE6FB"/>
                 </a:solidFill>
                 <a:latin typeface="Montserrat SemiBold" pitchFamily="34" charset="0"/>
                 <a:ea typeface="Montserrat SemiBold" pitchFamily="34" charset="-122"/>
@@ -4075,8 +4094,8 @@
         </p:nvSpPr>
         <p:spPr>
           <a:xfrm>
-            <a:off x="3200400" y="1536192"/>
-            <a:ext cx="3657600" cy="237744"/>
+            <a:off x="1188720" y="1536192"/>
+            <a:ext cx="7680960" cy="237744"/>
           </a:xfrm>
           <a:prstGeom prst="rect">
             <a:avLst/>
@@ -4114,8 +4133,8 @@
         </p:nvSpPr>
         <p:spPr>
           <a:xfrm>
-            <a:off x="1371600" y="1737360"/>
-            <a:ext cx="7315200" cy="777240"/>
+            <a:off x="1097280" y="1737360"/>
+            <a:ext cx="7863840" cy="777240"/>
           </a:xfrm>
           <a:prstGeom prst="rect">
             <a:avLst/>
@@ -4704,26 +4723,26 @@
         </p:nvSpPr>
         <p:spPr>
           <a:xfrm>
-            <a:off x="3657600" y="7370064"/>
-            <a:ext cx="2743200" cy="182880"/>
-          </a:xfrm>
-          <a:prstGeom prst="rect">
-            <a:avLst/>
-          </a:prstGeom>
-          <a:noFill/>
-          <a:ln/>
-        </p:spPr>
-        <p:txBody>
-          <a:bodyPr wrap="square" lIns="0" tIns="0" rIns="0" bIns="0" rtlCol="0" anchor="ctr"/>
-          <a:lstStyle/>
-          <a:p>
-            <a:pPr algn="ctr" indent="0" marL="0">
+            <a:off x="457200" y="7498080"/>
+            <a:ext cx="2286000" cy="219456"/>
+          </a:xfrm>
+          <a:prstGeom prst="rect">
+            <a:avLst/>
+          </a:prstGeom>
+          <a:noFill/>
+          <a:ln/>
+        </p:spPr>
+        <p:txBody>
+          <a:bodyPr wrap="square" lIns="0" tIns="0" rIns="0" bIns="0" rtlCol="0" anchor="ctr"/>
+          <a:lstStyle/>
+          <a:p>
+            <a:pPr algn="l" indent="0" marL="0">
               <a:buNone/>
             </a:pPr>
             <a:r>
               <a:rPr lang="en-US" sz="800" spc="100" kern="0" dirty="0">
                 <a:solidFill>
-                  <a:srgbClr val="8A99AB"/>
+                  <a:srgbClr val="CFE6FB"/>
                 </a:solidFill>
                 <a:latin typeface="Montserrat SemiBold" pitchFamily="34" charset="0"/>
                 <a:ea typeface="Montserrat SemiBold" pitchFamily="34" charset="-122"/>
@@ -4768,8 +4787,8 @@
         </p:nvSpPr>
         <p:spPr>
           <a:xfrm>
-            <a:off x="3200400" y="1536192"/>
-            <a:ext cx="3657600" cy="237744"/>
+            <a:off x="1188720" y="1536192"/>
+            <a:ext cx="7680960" cy="237744"/>
           </a:xfrm>
           <a:prstGeom prst="rect">
             <a:avLst/>
@@ -4807,8 +4826,8 @@
         </p:nvSpPr>
         <p:spPr>
           <a:xfrm>
-            <a:off x="1371600" y="1737360"/>
-            <a:ext cx="7315200" cy="777240"/>
+            <a:off x="1097280" y="1737360"/>
+            <a:ext cx="7863840" cy="777240"/>
           </a:xfrm>
           <a:prstGeom prst="rect">
             <a:avLst/>
@@ -5397,26 +5416,26 @@
         </p:nvSpPr>
         <p:spPr>
           <a:xfrm>
-            <a:off x="3657600" y="7370064"/>
-            <a:ext cx="2743200" cy="182880"/>
-          </a:xfrm>
-          <a:prstGeom prst="rect">
-            <a:avLst/>
-          </a:prstGeom>
-          <a:noFill/>
-          <a:ln/>
-        </p:spPr>
-        <p:txBody>
-          <a:bodyPr wrap="square" lIns="0" tIns="0" rIns="0" bIns="0" rtlCol="0" anchor="ctr"/>
-          <a:lstStyle/>
-          <a:p>
-            <a:pPr algn="ctr" indent="0" marL="0">
+            <a:off x="457200" y="7498080"/>
+            <a:ext cx="2286000" cy="219456"/>
+          </a:xfrm>
+          <a:prstGeom prst="rect">
+            <a:avLst/>
+          </a:prstGeom>
+          <a:noFill/>
+          <a:ln/>
+        </p:spPr>
+        <p:txBody>
+          <a:bodyPr wrap="square" lIns="0" tIns="0" rIns="0" bIns="0" rtlCol="0" anchor="ctr"/>
+          <a:lstStyle/>
+          <a:p>
+            <a:pPr algn="l" indent="0" marL="0">
               <a:buNone/>
             </a:pPr>
             <a:r>
               <a:rPr lang="en-US" sz="800" spc="100" kern="0" dirty="0">
                 <a:solidFill>
-                  <a:srgbClr val="8A99AB"/>
+                  <a:srgbClr val="CFE6FB"/>
                 </a:solidFill>
                 <a:latin typeface="Montserrat SemiBold" pitchFamily="34" charset="0"/>
                 <a:ea typeface="Montserrat SemiBold" pitchFamily="34" charset="-122"/>
@@ -5461,8 +5480,8 @@
         </p:nvSpPr>
         <p:spPr>
           <a:xfrm>
-            <a:off x="3200400" y="1536192"/>
-            <a:ext cx="3657600" cy="237744"/>
+            <a:off x="1188720" y="1536192"/>
+            <a:ext cx="7680960" cy="237744"/>
           </a:xfrm>
           <a:prstGeom prst="rect">
             <a:avLst/>
@@ -5500,8 +5519,8 @@
         </p:nvSpPr>
         <p:spPr>
           <a:xfrm>
-            <a:off x="1371600" y="1737360"/>
-            <a:ext cx="7315200" cy="777240"/>
+            <a:off x="1097280" y="1737360"/>
+            <a:ext cx="7863840" cy="777240"/>
           </a:xfrm>
           <a:prstGeom prst="rect">
             <a:avLst/>
@@ -6090,26 +6109,26 @@
         </p:nvSpPr>
         <p:spPr>
           <a:xfrm>
-            <a:off x="3657600" y="7370064"/>
-            <a:ext cx="2743200" cy="182880"/>
-          </a:xfrm>
-          <a:prstGeom prst="rect">
-            <a:avLst/>
-          </a:prstGeom>
-          <a:noFill/>
-          <a:ln/>
-        </p:spPr>
-        <p:txBody>
-          <a:bodyPr wrap="square" lIns="0" tIns="0" rIns="0" bIns="0" rtlCol="0" anchor="ctr"/>
-          <a:lstStyle/>
-          <a:p>
-            <a:pPr algn="ctr" indent="0" marL="0">
+            <a:off x="457200" y="7498080"/>
+            <a:ext cx="2286000" cy="219456"/>
+          </a:xfrm>
+          <a:prstGeom prst="rect">
+            <a:avLst/>
+          </a:prstGeom>
+          <a:noFill/>
+          <a:ln/>
+        </p:spPr>
+        <p:txBody>
+          <a:bodyPr wrap="square" lIns="0" tIns="0" rIns="0" bIns="0" rtlCol="0" anchor="ctr"/>
+          <a:lstStyle/>
+          <a:p>
+            <a:pPr algn="l" indent="0" marL="0">
               <a:buNone/>
             </a:pPr>
             <a:r>
               <a:rPr lang="en-US" sz="800" spc="100" kern="0" dirty="0">
                 <a:solidFill>
-                  <a:srgbClr val="8A99AB"/>
+                  <a:srgbClr val="CFE6FB"/>
                 </a:solidFill>
                 <a:latin typeface="Montserrat SemiBold" pitchFamily="34" charset="0"/>
                 <a:ea typeface="Montserrat SemiBold" pitchFamily="34" charset="-122"/>
@@ -6154,8 +6173,8 @@
         </p:nvSpPr>
         <p:spPr>
           <a:xfrm>
-            <a:off x="3200400" y="1536192"/>
-            <a:ext cx="3657600" cy="237744"/>
+            <a:off x="1188720" y="1536192"/>
+            <a:ext cx="7680960" cy="237744"/>
           </a:xfrm>
           <a:prstGeom prst="rect">
             <a:avLst/>
@@ -6193,8 +6212,8 @@
         </p:nvSpPr>
         <p:spPr>
           <a:xfrm>
-            <a:off x="1371600" y="1737360"/>
-            <a:ext cx="7315200" cy="777240"/>
+            <a:off x="1097280" y="1737360"/>
+            <a:ext cx="7863840" cy="777240"/>
           </a:xfrm>
           <a:prstGeom prst="rect">
             <a:avLst/>
@@ -6783,26 +6802,26 @@
         </p:nvSpPr>
         <p:spPr>
           <a:xfrm>
-            <a:off x="3657600" y="7370064"/>
-            <a:ext cx="2743200" cy="182880"/>
-          </a:xfrm>
-          <a:prstGeom prst="rect">
-            <a:avLst/>
-          </a:prstGeom>
-          <a:noFill/>
-          <a:ln/>
-        </p:spPr>
-        <p:txBody>
-          <a:bodyPr wrap="square" lIns="0" tIns="0" rIns="0" bIns="0" rtlCol="0" anchor="ctr"/>
-          <a:lstStyle/>
-          <a:p>
-            <a:pPr algn="ctr" indent="0" marL="0">
+            <a:off x="457200" y="7498080"/>
+            <a:ext cx="2286000" cy="219456"/>
+          </a:xfrm>
+          <a:prstGeom prst="rect">
+            <a:avLst/>
+          </a:prstGeom>
+          <a:noFill/>
+          <a:ln/>
+        </p:spPr>
+        <p:txBody>
+          <a:bodyPr wrap="square" lIns="0" tIns="0" rIns="0" bIns="0" rtlCol="0" anchor="ctr"/>
+          <a:lstStyle/>
+          <a:p>
+            <a:pPr algn="l" indent="0" marL="0">
               <a:buNone/>
             </a:pPr>
             <a:r>
               <a:rPr lang="en-US" sz="800" spc="100" kern="0" dirty="0">
                 <a:solidFill>
-                  <a:srgbClr val="8A99AB"/>
+                  <a:srgbClr val="CFE6FB"/>
                 </a:solidFill>
                 <a:latin typeface="Montserrat SemiBold" pitchFamily="34" charset="0"/>
                 <a:ea typeface="Montserrat SemiBold" pitchFamily="34" charset="-122"/>
@@ -6847,8 +6866,8 @@
         </p:nvSpPr>
         <p:spPr>
           <a:xfrm>
-            <a:off x="3200400" y="1536192"/>
-            <a:ext cx="3657600" cy="237744"/>
+            <a:off x="1188720" y="1536192"/>
+            <a:ext cx="7680960" cy="237744"/>
           </a:xfrm>
           <a:prstGeom prst="rect">
             <a:avLst/>
@@ -6886,8 +6905,8 @@
         </p:nvSpPr>
         <p:spPr>
           <a:xfrm>
-            <a:off x="1371600" y="1737360"/>
-            <a:ext cx="7315200" cy="777240"/>
+            <a:off x="1097280" y="1737360"/>
+            <a:ext cx="7863840" cy="777240"/>
           </a:xfrm>
           <a:prstGeom prst="rect">
             <a:avLst/>
@@ -7476,26 +7495,26 @@
         </p:nvSpPr>
         <p:spPr>
           <a:xfrm>
-            <a:off x="3657600" y="7370064"/>
-            <a:ext cx="2743200" cy="182880"/>
-          </a:xfrm>
-          <a:prstGeom prst="rect">
-            <a:avLst/>
-          </a:prstGeom>
-          <a:noFill/>
-          <a:ln/>
-        </p:spPr>
-        <p:txBody>
-          <a:bodyPr wrap="square" lIns="0" tIns="0" rIns="0" bIns="0" rtlCol="0" anchor="ctr"/>
-          <a:lstStyle/>
-          <a:p>
-            <a:pPr algn="ctr" indent="0" marL="0">
+            <a:off x="457200" y="7498080"/>
+            <a:ext cx="2286000" cy="219456"/>
+          </a:xfrm>
+          <a:prstGeom prst="rect">
+            <a:avLst/>
+          </a:prstGeom>
+          <a:noFill/>
+          <a:ln/>
+        </p:spPr>
+        <p:txBody>
+          <a:bodyPr wrap="square" lIns="0" tIns="0" rIns="0" bIns="0" rtlCol="0" anchor="ctr"/>
+          <a:lstStyle/>
+          <a:p>
+            <a:pPr algn="l" indent="0" marL="0">
               <a:buNone/>
             </a:pPr>
             <a:r>
               <a:rPr lang="en-US" sz="800" spc="100" kern="0" dirty="0">
                 <a:solidFill>
-                  <a:srgbClr val="8A99AB"/>
+                  <a:srgbClr val="CFE6FB"/>
                 </a:solidFill>
                 <a:latin typeface="Montserrat SemiBold" pitchFamily="34" charset="0"/>
                 <a:ea typeface="Montserrat SemiBold" pitchFamily="34" charset="-122"/>
@@ -7540,8 +7559,8 @@
         </p:nvSpPr>
         <p:spPr>
           <a:xfrm>
-            <a:off x="3200400" y="1536192"/>
-            <a:ext cx="3657600" cy="237744"/>
+            <a:off x="1188720" y="1536192"/>
+            <a:ext cx="7680960" cy="237744"/>
           </a:xfrm>
           <a:prstGeom prst="rect">
             <a:avLst/>
@@ -7579,8 +7598,8 @@
         </p:nvSpPr>
         <p:spPr>
           <a:xfrm>
-            <a:off x="1371600" y="1737360"/>
-            <a:ext cx="7315200" cy="777240"/>
+            <a:off x="1097280" y="1737360"/>
+            <a:ext cx="7863840" cy="777240"/>
           </a:xfrm>
           <a:prstGeom prst="rect">
             <a:avLst/>
@@ -8169,26 +8188,26 @@
         </p:nvSpPr>
         <p:spPr>
           <a:xfrm>
-            <a:off x="3657600" y="7370064"/>
-            <a:ext cx="2743200" cy="182880"/>
-          </a:xfrm>
-          <a:prstGeom prst="rect">
-            <a:avLst/>
-          </a:prstGeom>
-          <a:noFill/>
-          <a:ln/>
-        </p:spPr>
-        <p:txBody>
-          <a:bodyPr wrap="square" lIns="0" tIns="0" rIns="0" bIns="0" rtlCol="0" anchor="ctr"/>
-          <a:lstStyle/>
-          <a:p>
-            <a:pPr algn="ctr" indent="0" marL="0">
+            <a:off x="457200" y="7498080"/>
+            <a:ext cx="2286000" cy="219456"/>
+          </a:xfrm>
+          <a:prstGeom prst="rect">
+            <a:avLst/>
+          </a:prstGeom>
+          <a:noFill/>
+          <a:ln/>
+        </p:spPr>
+        <p:txBody>
+          <a:bodyPr wrap="square" lIns="0" tIns="0" rIns="0" bIns="0" rtlCol="0" anchor="ctr"/>
+          <a:lstStyle/>
+          <a:p>
+            <a:pPr algn="l" indent="0" marL="0">
               <a:buNone/>
             </a:pPr>
             <a:r>
               <a:rPr lang="en-US" sz="800" spc="100" kern="0" dirty="0">
                 <a:solidFill>
-                  <a:srgbClr val="8A99AB"/>
+                  <a:srgbClr val="CFE6FB"/>
                 </a:solidFill>
                 <a:latin typeface="Montserrat SemiBold" pitchFamily="34" charset="0"/>
                 <a:ea typeface="Montserrat SemiBold" pitchFamily="34" charset="-122"/>
@@ -8233,8 +8252,8 @@
         </p:nvSpPr>
         <p:spPr>
           <a:xfrm>
-            <a:off x="3200400" y="1536192"/>
-            <a:ext cx="3657600" cy="237744"/>
+            <a:off x="1188720" y="1536192"/>
+            <a:ext cx="7680960" cy="237744"/>
           </a:xfrm>
           <a:prstGeom prst="rect">
             <a:avLst/>
@@ -8272,8 +8291,8 @@
         </p:nvSpPr>
         <p:spPr>
           <a:xfrm>
-            <a:off x="1371600" y="1737360"/>
-            <a:ext cx="7315200" cy="777240"/>
+            <a:off x="1097280" y="1737360"/>
+            <a:ext cx="7863840" cy="777240"/>
           </a:xfrm>
           <a:prstGeom prst="rect">
             <a:avLst/>
@@ -8862,26 +8881,26 @@
         </p:nvSpPr>
         <p:spPr>
           <a:xfrm>
-            <a:off x="3657600" y="7370064"/>
-            <a:ext cx="2743200" cy="182880"/>
-          </a:xfrm>
-          <a:prstGeom prst="rect">
-            <a:avLst/>
-          </a:prstGeom>
-          <a:noFill/>
-          <a:ln/>
-        </p:spPr>
-        <p:txBody>
-          <a:bodyPr wrap="square" lIns="0" tIns="0" rIns="0" bIns="0" rtlCol="0" anchor="ctr"/>
-          <a:lstStyle/>
-          <a:p>
-            <a:pPr algn="ctr" indent="0" marL="0">
+            <a:off x="457200" y="7498080"/>
+            <a:ext cx="2286000" cy="219456"/>
+          </a:xfrm>
+          <a:prstGeom prst="rect">
+            <a:avLst/>
+          </a:prstGeom>
+          <a:noFill/>
+          <a:ln/>
+        </p:spPr>
+        <p:txBody>
+          <a:bodyPr wrap="square" lIns="0" tIns="0" rIns="0" bIns="0" rtlCol="0" anchor="ctr"/>
+          <a:lstStyle/>
+          <a:p>
+            <a:pPr algn="l" indent="0" marL="0">
               <a:buNone/>
             </a:pPr>
             <a:r>
               <a:rPr lang="en-US" sz="800" spc="100" kern="0" dirty="0">
                 <a:solidFill>
-                  <a:srgbClr val="8A99AB"/>
+                  <a:srgbClr val="CFE6FB"/>
                 </a:solidFill>
                 <a:latin typeface="Montserrat SemiBold" pitchFamily="34" charset="0"/>
                 <a:ea typeface="Montserrat SemiBold" pitchFamily="34" charset="-122"/>
@@ -8926,8 +8945,8 @@
         </p:nvSpPr>
         <p:spPr>
           <a:xfrm>
-            <a:off x="3200400" y="1536192"/>
-            <a:ext cx="3657600" cy="237744"/>
+            <a:off x="1188720" y="1536192"/>
+            <a:ext cx="7680960" cy="237744"/>
           </a:xfrm>
           <a:prstGeom prst="rect">
             <a:avLst/>
@@ -8965,8 +8984,8 @@
         </p:nvSpPr>
         <p:spPr>
           <a:xfrm>
-            <a:off x="1371600" y="1737360"/>
-            <a:ext cx="7315200" cy="777240"/>
+            <a:off x="1097280" y="1737360"/>
+            <a:ext cx="7863840" cy="777240"/>
           </a:xfrm>
           <a:prstGeom prst="rect">
             <a:avLst/>
@@ -9555,26 +9574,26 @@
         </p:nvSpPr>
         <p:spPr>
           <a:xfrm>
-            <a:off x="3657600" y="7370064"/>
-            <a:ext cx="2743200" cy="182880"/>
-          </a:xfrm>
-          <a:prstGeom prst="rect">
-            <a:avLst/>
-          </a:prstGeom>
-          <a:noFill/>
-          <a:ln/>
-        </p:spPr>
-        <p:txBody>
-          <a:bodyPr wrap="square" lIns="0" tIns="0" rIns="0" bIns="0" rtlCol="0" anchor="ctr"/>
-          <a:lstStyle/>
-          <a:p>
-            <a:pPr algn="ctr" indent="0" marL="0">
+            <a:off x="457200" y="7498080"/>
+            <a:ext cx="2286000" cy="219456"/>
+          </a:xfrm>
+          <a:prstGeom prst="rect">
+            <a:avLst/>
+          </a:prstGeom>
+          <a:noFill/>
+          <a:ln/>
+        </p:spPr>
+        <p:txBody>
+          <a:bodyPr wrap="square" lIns="0" tIns="0" rIns="0" bIns="0" rtlCol="0" anchor="ctr"/>
+          <a:lstStyle/>
+          <a:p>
+            <a:pPr algn="l" indent="0" marL="0">
               <a:buNone/>
             </a:pPr>
             <a:r>
               <a:rPr lang="en-US" sz="800" spc="100" kern="0" dirty="0">
                 <a:solidFill>
-                  <a:srgbClr val="8A99AB"/>
+                  <a:srgbClr val="CFE6FB"/>
                 </a:solidFill>
                 <a:latin typeface="Montserrat SemiBold" pitchFamily="34" charset="0"/>
                 <a:ea typeface="Montserrat SemiBold" pitchFamily="34" charset="-122"/>

</xml_diff>